<commit_message>
fixed the typo in arif's ppt
</commit_message>
<xml_diff>
--- a/Scientific Calculator C Presentation.pptx
+++ b/Scientific Calculator C Presentation.pptx
@@ -318,7 +318,7 @@
           <a:p>
             <a:fld id="{5BCAD085-E8A6-8845-BD4E-CB4CCA059FC4}" type="datetimeFigureOut">
               <a:rPr lang="en-US" smtClean="0"/>
-              <a:t>8/19/2026</a:t>
+              <a:t>8/20/2026</a:t>
             </a:fld>
             <a:endParaRPr lang="en-US"/>
           </a:p>
@@ -491,7 +491,7 @@
           <a:p>
             <a:fld id="{5BCAD085-E8A6-8845-BD4E-CB4CCA059FC4}" type="datetimeFigureOut">
               <a:rPr lang="en-US" smtClean="0"/>
-              <a:t>8/19/2026</a:t>
+              <a:t>8/20/2026</a:t>
             </a:fld>
             <a:endParaRPr lang="en-US"/>
           </a:p>
@@ -674,7 +674,7 @@
           <a:p>
             <a:fld id="{5BCAD085-E8A6-8845-BD4E-CB4CCA059FC4}" type="datetimeFigureOut">
               <a:rPr lang="en-US" smtClean="0"/>
-              <a:t>8/19/2026</a:t>
+              <a:t>8/20/2026</a:t>
             </a:fld>
             <a:endParaRPr lang="en-US"/>
           </a:p>
@@ -847,7 +847,7 @@
           <a:p>
             <a:fld id="{5BCAD085-E8A6-8845-BD4E-CB4CCA059FC4}" type="datetimeFigureOut">
               <a:rPr lang="en-US" smtClean="0"/>
-              <a:t>8/19/2026</a:t>
+              <a:t>8/20/2026</a:t>
             </a:fld>
             <a:endParaRPr lang="en-US"/>
           </a:p>
@@ -1096,7 +1096,7 @@
           <a:p>
             <a:fld id="{5BCAD085-E8A6-8845-BD4E-CB4CCA059FC4}" type="datetimeFigureOut">
               <a:rPr lang="en-US" smtClean="0"/>
-              <a:t>8/19/2026</a:t>
+              <a:t>8/20/2026</a:t>
             </a:fld>
             <a:endParaRPr lang="en-US"/>
           </a:p>
@@ -1387,7 +1387,7 @@
           <a:p>
             <a:fld id="{5BCAD085-E8A6-8845-BD4E-CB4CCA059FC4}" type="datetimeFigureOut">
               <a:rPr lang="en-US" smtClean="0"/>
-              <a:t>8/19/2026</a:t>
+              <a:t>8/20/2026</a:t>
             </a:fld>
             <a:endParaRPr lang="en-US"/>
           </a:p>
@@ -1812,7 +1812,7 @@
           <a:p>
             <a:fld id="{5BCAD085-E8A6-8845-BD4E-CB4CCA059FC4}" type="datetimeFigureOut">
               <a:rPr lang="en-US" smtClean="0"/>
-              <a:t>8/19/2026</a:t>
+              <a:t>8/20/2026</a:t>
             </a:fld>
             <a:endParaRPr lang="en-US"/>
           </a:p>
@@ -1933,7 +1933,7 @@
           <a:p>
             <a:fld id="{5BCAD085-E8A6-8845-BD4E-CB4CCA059FC4}" type="datetimeFigureOut">
               <a:rPr lang="en-US" smtClean="0"/>
-              <a:t>8/19/2026</a:t>
+              <a:t>8/20/2026</a:t>
             </a:fld>
             <a:endParaRPr lang="en-US"/>
           </a:p>
@@ -2031,7 +2031,7 @@
           <a:p>
             <a:fld id="{5BCAD085-E8A6-8845-BD4E-CB4CCA059FC4}" type="datetimeFigureOut">
               <a:rPr lang="en-US" smtClean="0"/>
-              <a:t>8/19/2026</a:t>
+              <a:t>8/20/2026</a:t>
             </a:fld>
             <a:endParaRPr lang="en-US"/>
           </a:p>
@@ -2311,7 +2311,7 @@
           <a:p>
             <a:fld id="{5BCAD085-E8A6-8845-BD4E-CB4CCA059FC4}" type="datetimeFigureOut">
               <a:rPr lang="en-US" smtClean="0"/>
-              <a:t>8/19/2026</a:t>
+              <a:t>8/20/2026</a:t>
             </a:fld>
             <a:endParaRPr lang="en-US"/>
           </a:p>
@@ -2567,7 +2567,7 @@
           <a:p>
             <a:fld id="{5BCAD085-E8A6-8845-BD4E-CB4CCA059FC4}" type="datetimeFigureOut">
               <a:rPr lang="en-US" smtClean="0"/>
-              <a:t>8/19/2026</a:t>
+              <a:t>8/20/2026</a:t>
             </a:fld>
             <a:endParaRPr lang="en-US"/>
           </a:p>
@@ -2783,7 +2783,7 @@
           <a:p>
             <a:fld id="{5BCAD085-E8A6-8845-BD4E-CB4CCA059FC4}" type="datetimeFigureOut">
               <a:rPr lang="en-US" smtClean="0"/>
-              <a:t>8/19/2026</a:t>
+              <a:t>8/20/2026</a:t>
             </a:fld>
             <a:endParaRPr lang="en-US"/>
           </a:p>
@@ -5946,13 +5946,22 @@
               <a:t>= </a:t>
             </a:r>
             <a:r>
+              <a:rPr lang="en-US" sz="1700" dirty="0" smtClean="0">
+                <a:solidFill>
+                  <a:srgbClr val="CBD5E1"/>
+                </a:solidFill>
+                <a:latin typeface="Inter"/>
+              </a:rPr>
+              <a:t>20</a:t>
+            </a:r>
+            <a:r>
               <a:rPr sz="1700" b="0" i="0" u="none" dirty="0" smtClean="0">
                 <a:solidFill>
                   <a:srgbClr val="CBD5E1"/>
                 </a:solidFill>
                 <a:latin typeface="Inter"/>
               </a:rPr>
-              <a:t>170.</a:t>
+              <a:t>.</a:t>
             </a:r>
             <a:endParaRPr sz="1700" b="0" i="0" u="none" dirty="0">
               <a:solidFill>
@@ -7296,7 +7305,7 @@
       </p:pic>
       <p:pic>
         <p:nvPicPr>
-          <p:cNvPr id="19" name="Picture 18" descr="image.png"/>
+          <p:cNvPr id="20" name="Picture 19" descr="image.png"/>
           <p:cNvPicPr>
             <a:picLocks noChangeAspect="1"/>
           </p:cNvPicPr>
@@ -7310,31 +7319,7 @@
         </p:blipFill>
         <p:spPr>
           <a:xfrm>
-            <a:off x="2649586" y="4412940"/>
-            <a:ext cx="1880849" cy="408090"/>
-          </a:xfrm>
-          <a:prstGeom prst="rect">
-            <a:avLst/>
-          </a:prstGeom>
-        </p:spPr>
-      </p:pic>
-      <p:pic>
-        <p:nvPicPr>
-          <p:cNvPr id="20" name="Picture 19" descr="image.png"/>
-          <p:cNvPicPr>
-            <a:picLocks noChangeAspect="1"/>
-          </p:cNvPicPr>
-          <p:nvPr/>
-        </p:nvPicPr>
-        <p:blipFill>
-          <a:blip r:embed="rId8"/>
-          <a:stretch>
-            <a:fillRect/>
-          </a:stretch>
-        </p:blipFill>
-        <p:spPr>
-          <a:xfrm>
-            <a:off x="2066925" y="4901505"/>
+            <a:off x="2066925" y="4693683"/>
             <a:ext cx="1028700" cy="185439"/>
           </a:xfrm>
           <a:prstGeom prst="rect">

</xml_diff>